<commit_message>
Math deck formatting: unwrap formula trio, trap banner clear of footer, mission caption matches layout
Co-Authored-By: Claude Fable 5 <noreply@anthropic.com>
</commit_message>
<xml_diff>
--- a/OPIM5509_Module3_Files/slides/Math for a Simple ConvNet.pptx
+++ b/OPIM5509_Module3_Files/slides/Math for a Simple ConvNet.pptx
@@ -24554,7 +24554,7 @@
                 </a:solidFill>
                 <a:latin typeface="Arial"/>
               </a:rPr>
-              <a:t>Given the code on the left, can you produce the summary on the right - every shape, every parameter count - BY HAND?</a:t>
+              <a:t>Given the code on the right, can you produce the summary on the left - every shape, every parameter count - BY HAND?</a:t>
             </a:r>
           </a:p>
           <a:p>
@@ -29272,7 +29272,7 @@
         </p:nvSpPr>
         <p:spPr>
           <a:xfrm>
-            <a:off x="2606040" y="5989320"/>
+            <a:off x="2606040" y="5742432"/>
             <a:ext cx="8778240" cy="502920"/>
           </a:xfrm>
           <a:prstGeom prst="roundRect">
@@ -29318,7 +29318,7 @@
         </p:nvSpPr>
         <p:spPr>
           <a:xfrm>
-            <a:off x="2834640" y="6080760"/>
+            <a:off x="2834640" y="5833872"/>
             <a:ext cx="8412480" cy="365760"/>
           </a:xfrm>
           <a:prstGeom prst="rect">
@@ -29928,13 +29928,13 @@
               </a:lnSpc>
             </a:pPr>
             <a:r>
-              <a:rPr sz="2500" b="1">
+              <a:rPr sz="2300" b="1">
                 <a:solidFill>
                   <a:srgbClr val="1C1E24"/>
                 </a:solidFill>
                 <a:latin typeface="Arial"/>
               </a:rPr>
-              <a:t>Conv2D:  ((M x N x L) + B) x F        Dense:  (n + 1) x m        Pooling / Flatten:  0</a:t>
+              <a:t>Conv2D: ((M x N x L) + B) x F      Dense: (n + 1) x m      Pool/Flatten: 0</a:t>
             </a:r>
           </a:p>
           <a:p>

</xml_diff>

<commit_message>
M3.1 decks v2: second conv makes 5 maps (140 parms, total 32,988); theory deck with recording-day fixes; generators updated (theory save now guarded)
Co-Authored-By: Claude Fable 5 <noreply@anthropic.com>
</commit_message>
<xml_diff>
--- a/OPIM5509_Module3_Files/slides/Math for a Simple ConvNet.pptx
+++ b/OPIM5509_Module3_Files/slides/Math for a Simple ConvNet.pptx
@@ -600,7 +600,7 @@
           <a:lstStyle/>
           <a:p>
             <a:r>
-              <a:t>THE TRAP SLIDE. L=3 because pooling handed us 3 maps. Each filter is a 3x3x3 brick: 27 weights + 1 bias, x3 filters = 84.</a:t>
+              <a:t>THE TRAP SLIDE. L=3 because pooling handed us 3 maps; F=5 because WE asked for 5. Each filter is a 3x3x3 brick (27 weights + 1 bias = 28), x5 filters = 140. Three in, five out - the two numbers do different jobs!</a:t>
             </a:r>
           </a:p>
         </p:txBody>
@@ -670,7 +670,7 @@
           <a:lstStyle/>
           <a:p>
             <a:r>
-              <a:t>Halve it again. Dense 5x5x3 nuggets of information now.</a:t>
+              <a:t>Halve it again. Dense 5x5x5 nuggets of information now.</a:t>
             </a:r>
           </a:p>
         </p:txBody>
@@ -740,7 +740,7 @@
           <a:lstStyle/>
           <a:p>
             <a:r>
-              <a:t>Unroll the maps into one row of 75 numbers - like the first row of a dataframe. Ready for dense layers.</a:t>
+              <a:t>Unroll the maps into one row of 125 numbers - like the first row of a dataframe. Ready for dense layers.</a:t>
             </a:r>
           </a:p>
         </p:txBody>
@@ -1230,7 +1230,7 @@
           <a:lstStyle/>
           <a:p>
             <a:r>
-              <a:t>Optional to record - students love the handwritten pass.</a:t>
+              <a:t>Optional to record - flip through a couple of kernels and connect back to the setosa demo from video 1.</a:t>
             </a:r>
           </a:p>
         </p:txBody>
@@ -1300,7 +1300,7 @@
           <a:lstStyle/>
           <a:p>
             <a:r>
-              <a:t>Code &lt;-&gt; summary in both directions.</a:t>
+              <a:t>Code &lt;-&gt; summary in both directions. NOTE: the second conv now makes FIVE maps - 3 in, 5 out, so nobody can confuse the two roles.</a:t>
             </a:r>
           </a:p>
         </p:txBody>
@@ -1440,7 +1440,7 @@
           <a:lstStyle/>
           <a:p>
             <a:r>
-              <a:t>The hook: 407K vs 20K.</a:t>
+              <a:t>The hook: 407K vs 33K.</a:t>
             </a:r>
           </a:p>
         </p:txBody>
@@ -7578,7 +7578,7 @@
                 </a:solidFill>
                 <a:latin typeface="Arial"/>
               </a:rPr>
-              <a:t>Layer 3 - Conv2D: 3 maps @ 3x3</a:t>
+              <a:t>Layer 3 - Conv2D: 5 maps @ 3x3</a:t>
             </a:r>
           </a:p>
         </p:txBody>
@@ -8285,7 +8285,7 @@
                 </a:solidFill>
                 <a:latin typeface="Arial"/>
               </a:rPr>
-              <a:t>Conv2D 3 @ 3x3</a:t>
+              <a:t>Conv2D 5 @ 3x3</a:t>
             </a:r>
           </a:p>
         </p:txBody>
@@ -8320,7 +8320,7 @@
                 </a:solidFill>
                 <a:latin typeface="Arial"/>
               </a:rPr>
-              <a:t>(None, 10, 10, 3)</a:t>
+              <a:t>(None, 10, 10, 5)</a:t>
             </a:r>
           </a:p>
         </p:txBody>
@@ -8401,7 +8401,7 @@
                 </a:solidFill>
                 <a:latin typeface="Arial"/>
               </a:rPr>
-              <a:t>84</a:t>
+              <a:t>140</a:t>
             </a:r>
           </a:p>
         </p:txBody>
@@ -8555,7 +8555,7 @@
                 </a:solidFill>
                 <a:latin typeface="Arial"/>
               </a:rPr>
-              <a:t>(None, 5, 5, 3)</a:t>
+              <a:t>(None, 5, 5, 5)</a:t>
             </a:r>
           </a:p>
         </p:txBody>
@@ -8709,7 +8709,7 @@
                 </a:solidFill>
                 <a:latin typeface="Arial"/>
               </a:rPr>
-              <a:t>(None, 75)</a:t>
+              <a:t>(None, 125)</a:t>
             </a:r>
           </a:p>
         </p:txBody>
@@ -9171,7 +9171,7 @@
                 </a:solidFill>
                 <a:latin typeface="Arial"/>
               </a:rPr>
-              <a:t>= 10   -&gt;   (None, 10, 10, 3)</a:t>
+              <a:t>= 10   -&gt;   (None, 10, 10, 5)</a:t>
             </a:r>
           </a:p>
         </p:txBody>
@@ -9293,7 +9293,7 @@
                 </a:solidFill>
                 <a:latin typeface="Arial"/>
               </a:rPr>
-              <a:t>((3 x 3 x 3) + 1) x 3</a:t>
+              <a:t>((3 x 3 x 3) + 1) x 5</a:t>
             </a:r>
           </a:p>
           <a:p>
@@ -9325,7 +9325,7 @@
                 </a:solidFill>
                 <a:latin typeface="Arial"/>
               </a:rPr>
-              <a:t>= 84 parms</a:t>
+              <a:t>= 140 parms</a:t>
             </a:r>
           </a:p>
         </p:txBody>
@@ -9415,7 +9415,7 @@
                 </a:solidFill>
                 <a:latin typeface="Arial"/>
               </a:rPr>
-              <a:t>78 + 84 = 162</a:t>
+              <a:t>78 + 140 = 218</a:t>
             </a:r>
           </a:p>
         </p:txBody>
@@ -9496,7 +9496,7 @@
                 </a:solidFill>
                 <a:latin typeface="Arial"/>
               </a:rPr>
-              <a:t>CAREFUL: L = 3 now - the previous layer made 3 maps!</a:t>
+              <a:t>CAREFUL: L = 3 (maps coming IN), F = 5 (maps we MAKE)!</a:t>
             </a:r>
           </a:p>
         </p:txBody>
@@ -10537,7 +10537,7 @@
                 </a:solidFill>
                 <a:latin typeface="Arial"/>
               </a:rPr>
-              <a:t>Conv2D 3 @ 3x3</a:t>
+              <a:t>Conv2D 5 @ 3x3</a:t>
             </a:r>
           </a:p>
         </p:txBody>
@@ -10572,7 +10572,7 @@
                 </a:solidFill>
                 <a:latin typeface="Arial"/>
               </a:rPr>
-              <a:t>(None, 10, 10, 3)</a:t>
+              <a:t>(None, 10, 10, 5)</a:t>
             </a:r>
           </a:p>
         </p:txBody>
@@ -10653,7 +10653,7 @@
                 </a:solidFill>
                 <a:latin typeface="Arial"/>
               </a:rPr>
-              <a:t>84</a:t>
+              <a:t>140</a:t>
             </a:r>
           </a:p>
         </p:txBody>
@@ -10807,7 +10807,7 @@
                 </a:solidFill>
                 <a:latin typeface="Arial"/>
               </a:rPr>
-              <a:t>(None, 5, 5, 3)</a:t>
+              <a:t>(None, 5, 5, 5)</a:t>
             </a:r>
           </a:p>
         </p:txBody>
@@ -11042,7 +11042,7 @@
                 </a:solidFill>
                 <a:latin typeface="Arial"/>
               </a:rPr>
-              <a:t>(None, 75)</a:t>
+              <a:t>(None, 125)</a:t>
             </a:r>
           </a:p>
         </p:txBody>
@@ -11504,7 +11504,7 @@
                 </a:solidFill>
                 <a:latin typeface="Arial"/>
               </a:rPr>
-              <a:t>= 5   -&gt;   (None, 5, 5, 3)</a:t>
+              <a:t>= 5   -&gt;   (None, 5, 5, 5)</a:t>
             </a:r>
           </a:p>
         </p:txBody>
@@ -11748,7 +11748,7 @@
                 </a:solidFill>
                 <a:latin typeface="Arial"/>
               </a:rPr>
-              <a:t>162</a:t>
+              <a:t>218</a:t>
             </a:r>
           </a:p>
         </p:txBody>
@@ -12789,7 +12789,7 @@
                 </a:solidFill>
                 <a:latin typeface="Arial"/>
               </a:rPr>
-              <a:t>Conv2D 3 @ 3x3</a:t>
+              <a:t>Conv2D 5 @ 3x3</a:t>
             </a:r>
           </a:p>
         </p:txBody>
@@ -12824,7 +12824,7 @@
                 </a:solidFill>
                 <a:latin typeface="Arial"/>
               </a:rPr>
-              <a:t>(None, 10, 10, 3)</a:t>
+              <a:t>(None, 10, 10, 5)</a:t>
             </a:r>
           </a:p>
         </p:txBody>
@@ -12905,7 +12905,7 @@
                 </a:solidFill>
                 <a:latin typeface="Arial"/>
               </a:rPr>
-              <a:t>84</a:t>
+              <a:t>140</a:t>
             </a:r>
           </a:p>
         </p:txBody>
@@ -13059,7 +13059,7 @@
                 </a:solidFill>
                 <a:latin typeface="Arial"/>
               </a:rPr>
-              <a:t>(None, 5, 5, 3)</a:t>
+              <a:t>(None, 5, 5, 5)</a:t>
             </a:r>
           </a:p>
         </p:txBody>
@@ -13294,7 +13294,7 @@
                 </a:solidFill>
                 <a:latin typeface="Arial"/>
               </a:rPr>
-              <a:t>(None, 75)</a:t>
+              <a:t>(None, 125)</a:t>
             </a:r>
           </a:p>
         </p:txBody>
@@ -13805,7 +13805,7 @@
                 </a:solidFill>
                 <a:latin typeface="Arial"/>
               </a:rPr>
-              <a:t>5 x 5 x 3</a:t>
+              <a:t>5 x 5 x 5</a:t>
             </a:r>
           </a:p>
           <a:p>
@@ -13837,7 +13837,7 @@
                 </a:solidFill>
                 <a:latin typeface="Arial"/>
               </a:rPr>
-              <a:t>= 75   -&gt;   (None, 75)</a:t>
+              <a:t>= 125   -&gt;   (None, 125)</a:t>
             </a:r>
           </a:p>
         </p:txBody>
@@ -14081,7 +14081,7 @@
                 </a:solidFill>
                 <a:latin typeface="Arial"/>
               </a:rPr>
-              <a:t>162</a:t>
+              <a:t>218</a:t>
             </a:r>
           </a:p>
         </p:txBody>
@@ -15122,7 +15122,7 @@
                 </a:solidFill>
                 <a:latin typeface="Arial"/>
               </a:rPr>
-              <a:t>Conv2D 3 @ 3x3</a:t>
+              <a:t>Conv2D 5 @ 3x3</a:t>
             </a:r>
           </a:p>
         </p:txBody>
@@ -15157,7 +15157,7 @@
                 </a:solidFill>
                 <a:latin typeface="Arial"/>
               </a:rPr>
-              <a:t>(None, 10, 10, 3)</a:t>
+              <a:t>(None, 10, 10, 5)</a:t>
             </a:r>
           </a:p>
         </p:txBody>
@@ -15238,7 +15238,7 @@
                 </a:solidFill>
                 <a:latin typeface="Arial"/>
               </a:rPr>
-              <a:t>84</a:t>
+              <a:t>140</a:t>
             </a:r>
           </a:p>
         </p:txBody>
@@ -15392,7 +15392,7 @@
                 </a:solidFill>
                 <a:latin typeface="Arial"/>
               </a:rPr>
-              <a:t>(None, 5, 5, 3)</a:t>
+              <a:t>(None, 5, 5, 5)</a:t>
             </a:r>
           </a:p>
         </p:txBody>
@@ -15627,7 +15627,7 @@
                 </a:solidFill>
                 <a:latin typeface="Arial"/>
               </a:rPr>
-              <a:t>(None, 75)</a:t>
+              <a:t>(None, 125)</a:t>
             </a:r>
           </a:p>
         </p:txBody>
@@ -15943,7 +15943,7 @@
                 </a:solidFill>
                 <a:latin typeface="Arial"/>
               </a:rPr>
-              <a:t>19,456</a:t>
+              <a:t>32,256</a:t>
             </a:r>
           </a:p>
         </p:txBody>
@@ -16373,7 +16373,7 @@
                 </a:solidFill>
                 <a:latin typeface="Arial"/>
               </a:rPr>
-              <a:t>(75 + 1) x 256</a:t>
+              <a:t>(125 + 1) x 256</a:t>
             </a:r>
           </a:p>
           <a:p>
@@ -16405,7 +16405,7 @@
                 </a:solidFill>
                 <a:latin typeface="Arial"/>
               </a:rPr>
-              <a:t>= 19,456 parms</a:t>
+              <a:t>= 32,256 parms</a:t>
             </a:r>
           </a:p>
         </p:txBody>
@@ -16495,7 +16495,7 @@
                 </a:solidFill>
                 <a:latin typeface="Arial"/>
               </a:rPr>
-              <a:t>162 + 19,456 = 19,618</a:t>
+              <a:t>218 + 32,256 = 32,474</a:t>
             </a:r>
           </a:p>
         </p:txBody>
@@ -17536,7 +17536,7 @@
                 </a:solidFill>
                 <a:latin typeface="Arial"/>
               </a:rPr>
-              <a:t>Conv2D 3 @ 3x3</a:t>
+              <a:t>Conv2D 5 @ 3x3</a:t>
             </a:r>
           </a:p>
         </p:txBody>
@@ -17571,7 +17571,7 @@
                 </a:solidFill>
                 <a:latin typeface="Arial"/>
               </a:rPr>
-              <a:t>(None, 10, 10, 3)</a:t>
+              <a:t>(None, 10, 10, 5)</a:t>
             </a:r>
           </a:p>
         </p:txBody>
@@ -17652,7 +17652,7 @@
                 </a:solidFill>
                 <a:latin typeface="Arial"/>
               </a:rPr>
-              <a:t>84</a:t>
+              <a:t>140</a:t>
             </a:r>
           </a:p>
         </p:txBody>
@@ -17806,7 +17806,7 @@
                 </a:solidFill>
                 <a:latin typeface="Arial"/>
               </a:rPr>
-              <a:t>(None, 5, 5, 3)</a:t>
+              <a:t>(None, 5, 5, 5)</a:t>
             </a:r>
           </a:p>
         </p:txBody>
@@ -18041,7 +18041,7 @@
                 </a:solidFill>
                 <a:latin typeface="Arial"/>
               </a:rPr>
-              <a:t>(None, 75)</a:t>
+              <a:t>(None, 125)</a:t>
             </a:r>
           </a:p>
         </p:txBody>
@@ -18357,7 +18357,7 @@
                 </a:solidFill>
                 <a:latin typeface="Arial"/>
               </a:rPr>
-              <a:t>19,456</a:t>
+              <a:t>32,256</a:t>
             </a:r>
           </a:p>
         </p:txBody>
@@ -18990,7 +18990,7 @@
                 </a:solidFill>
                 <a:latin typeface="Arial"/>
               </a:rPr>
-              <a:t>19,618 + 514 = 20,132</a:t>
+              <a:t>32,474 + 514 = 32,988</a:t>
             </a:r>
           </a:p>
         </p:txBody>
@@ -20031,7 +20031,7 @@
                 </a:solidFill>
                 <a:latin typeface="Arial"/>
               </a:rPr>
-              <a:t>Conv2D 3 @ 3x3</a:t>
+              <a:t>Conv2D 5 @ 3x3</a:t>
             </a:r>
           </a:p>
         </p:txBody>
@@ -20066,7 +20066,7 @@
                 </a:solidFill>
                 <a:latin typeface="Arial"/>
               </a:rPr>
-              <a:t>(None, 10, 10, 3)</a:t>
+              <a:t>(None, 10, 10, 5)</a:t>
             </a:r>
           </a:p>
         </p:txBody>
@@ -20147,7 +20147,7 @@
                 </a:solidFill>
                 <a:latin typeface="Arial"/>
               </a:rPr>
-              <a:t>84</a:t>
+              <a:t>140</a:t>
             </a:r>
           </a:p>
         </p:txBody>
@@ -20301,7 +20301,7 @@
                 </a:solidFill>
                 <a:latin typeface="Arial"/>
               </a:rPr>
-              <a:t>(None, 5, 5, 3)</a:t>
+              <a:t>(None, 5, 5, 5)</a:t>
             </a:r>
           </a:p>
         </p:txBody>
@@ -20536,7 +20536,7 @@
                 </a:solidFill>
                 <a:latin typeface="Arial"/>
               </a:rPr>
-              <a:t>(None, 75)</a:t>
+              <a:t>(None, 125)</a:t>
             </a:r>
           </a:p>
         </p:txBody>
@@ -20852,7 +20852,7 @@
                 </a:solidFill>
                 <a:latin typeface="Arial"/>
               </a:rPr>
-              <a:t>19,456</a:t>
+              <a:t>32,256</a:t>
             </a:r>
           </a:p>
         </p:txBody>
@@ -21174,7 +21174,7 @@
                 </a:solidFill>
                 <a:latin typeface="Arial"/>
               </a:rPr>
-              <a:t>TOTAL  =  78 + 84 + 19,456 + 514  =  20,132</a:t>
+              <a:t>TOTAL  =  78 + 140 + 32,256 + 514  =  32,988</a:t>
             </a:r>
           </a:p>
           <a:p>
@@ -24168,7 +24168,7 @@
                 </a:solidFill>
                 <a:latin typeface="Arial"/>
               </a:rPr>
-              <a:t>The same math, by hand</a:t>
+              <a:t>Kernels in action: the gallery</a:t>
             </a:r>
           </a:p>
         </p:txBody>
@@ -24203,7 +24203,7 @@
                 </a:solidFill>
                 <a:latin typeface="Arial"/>
               </a:rPr>
-              <a:t>My handwritten walkthrough of the full chain - keep it next to the notebook when you practice.</a:t>
+              <a:t>Screenshots from setosa.io/ev/image-kernels: the same face through different kernels - watch the dot product panel build each output pixel.</a:t>
             </a:r>
           </a:p>
         </p:txBody>
@@ -24472,54 +24472,87 @@
           </a:p>
         </p:txBody>
       </p:sp>
-      <p:pic>
-        <p:nvPicPr>
-          <p:cNvPr id="6" name="Picture 5" descr="s02_img3.png"/>
-          <p:cNvPicPr>
-            <a:picLocks noChangeAspect="1"/>
-          </p:cNvPicPr>
-          <p:nvPr/>
-        </p:nvPicPr>
-        <p:blipFill>
-          <a:blip r:embed="rId2"/>
-          <a:stretch>
-            <a:fillRect/>
-          </a:stretch>
-        </p:blipFill>
-        <p:spPr>
-          <a:xfrm>
-            <a:off x="777240" y="1920404"/>
-            <a:ext cx="5212080" cy="3840150"/>
-          </a:xfrm>
-          <a:prstGeom prst="rect">
-            <a:avLst/>
-          </a:prstGeom>
-        </p:spPr>
-      </p:pic>
-      <p:pic>
-        <p:nvPicPr>
-          <p:cNvPr id="7" name="Picture 6" descr="s02_img4.png"/>
-          <p:cNvPicPr>
-            <a:picLocks noChangeAspect="1"/>
-          </p:cNvPicPr>
-          <p:nvPr/>
-        </p:nvPicPr>
-        <p:blipFill>
-          <a:blip r:embed="rId3"/>
-          <a:stretch>
-            <a:fillRect/>
-          </a:stretch>
-        </p:blipFill>
-        <p:spPr>
-          <a:xfrm>
-            <a:off x="6263640" y="2218363"/>
-            <a:ext cx="5212080" cy="2421273"/>
-          </a:xfrm>
-          <a:prstGeom prst="rect">
-            <a:avLst/>
-          </a:prstGeom>
-        </p:spPr>
-      </p:pic>
+      <p:sp>
+        <p:nvSpPr>
+          <p:cNvPr id="6" name="Rounded Rectangle 5"/>
+          <p:cNvSpPr/>
+          <p:nvPr/>
+        </p:nvSpPr>
+        <p:spPr>
+          <a:xfrm>
+            <a:off x="777240" y="1874519"/>
+            <a:ext cx="5394960" cy="3977639"/>
+          </a:xfrm>
+          <a:prstGeom prst="roundRect">
+            <a:avLst>
+              <a:gd name="adj" fmla="val 4000"/>
+            </a:avLst>
+          </a:prstGeom>
+          <a:solidFill>
+            <a:srgbClr val="181A20"/>
+          </a:solidFill>
+          <a:ln>
+            <a:noFill/>
+          </a:ln>
+          <a:effectLst/>
+        </p:spPr>
+        <p:style>
+          <a:lnRef idx="1">
+            <a:schemeClr val="accent1"/>
+          </a:lnRef>
+          <a:fillRef idx="3">
+            <a:schemeClr val="accent1"/>
+          </a:fillRef>
+          <a:effectRef idx="2">
+            <a:schemeClr val="accent1"/>
+          </a:effectRef>
+          <a:fontRef idx="minor">
+            <a:schemeClr val="lt1"/>
+          </a:fontRef>
+        </p:style>
+        <p:txBody>
+          <a:bodyPr rtlCol="0" anchor="ctr"/>
+          <a:lstStyle/>
+          <a:p>
+            <a:pPr algn="ctr"/>
+          </a:p>
+        </p:txBody>
+      </p:sp>
+      <p:sp>
+        <p:nvSpPr>
+          <p:cNvPr id="7" name="TextBox 6"/>
+          <p:cNvSpPr txBox="1"/>
+          <p:nvPr/>
+        </p:nvSpPr>
+        <p:spPr>
+          <a:xfrm>
+            <a:off x="1051560" y="2057400"/>
+            <a:ext cx="4846320" cy="320040"/>
+          </a:xfrm>
+          <a:prstGeom prst="rect">
+            <a:avLst/>
+          </a:prstGeom>
+          <a:noFill/>
+        </p:spPr>
+        <p:txBody>
+          <a:bodyPr wrap="square" anchor="t" lIns="0" rIns="0" tIns="0" bIns="0">
+            <a:spAutoFit/>
+          </a:bodyPr>
+          <a:lstStyle/>
+          <a:p>
+            <a:pPr algn="l"/>
+            <a:r>
+              <a:rPr sz="1300" b="1">
+                <a:solidFill>
+                  <a:srgbClr val="FAD878"/>
+                </a:solidFill>
+                <a:latin typeface="Arial"/>
+              </a:rPr>
+              <a:t>THE CODE</a:t>
+            </a:r>
+          </a:p>
+        </p:txBody>
+      </p:sp>
       <p:sp>
         <p:nvSpPr>
           <p:cNvPr id="8" name="TextBox 7"/>
@@ -24528,43 +24561,1411 @@
         </p:nvSpPr>
         <p:spPr>
           <a:xfrm>
-            <a:off x="6263640" y="5029200"/>
-            <a:ext cx="5212080" cy="1005840"/>
-          </a:xfrm>
-          <a:prstGeom prst="rect">
-            <a:avLst/>
-          </a:prstGeom>
-          <a:noFill/>
-        </p:spPr>
-        <p:txBody>
-          <a:bodyPr wrap="square" anchor="t" lIns="0" rIns="0" tIns="0" bIns="0">
-            <a:spAutoFit/>
-          </a:bodyPr>
-          <a:lstStyle/>
-          <a:p>
-            <a:pPr algn="l">
-              <a:lnSpc>
-                <a:spcPct val="110000"/>
-              </a:lnSpc>
-            </a:pPr>
-            <a:r>
-              <a:rPr sz="1700" b="1">
+            <a:off x="1051560" y="2395728"/>
+            <a:ext cx="5029200" cy="246888"/>
+          </a:xfrm>
+          <a:prstGeom prst="rect">
+            <a:avLst/>
+          </a:prstGeom>
+          <a:noFill/>
+        </p:spPr>
+        <p:txBody>
+          <a:bodyPr wrap="square" anchor="t" lIns="0" rIns="0" tIns="0" bIns="0">
+            <a:spAutoFit/>
+          </a:bodyPr>
+          <a:lstStyle/>
+          <a:p>
+            <a:pPr algn="l"/>
+            <a:r>
+              <a:rPr sz="1300" b="0">
+                <a:solidFill>
+                  <a:srgbClr val="D8DAE2"/>
+                </a:solidFill>
+                <a:latin typeface="Consolas"/>
+              </a:rPr>
+              <a:t>from tensorflow.keras import layers, models</a:t>
+            </a:r>
+          </a:p>
+        </p:txBody>
+      </p:sp>
+      <p:sp>
+        <p:nvSpPr>
+          <p:cNvPr id="9" name="TextBox 8"/>
+          <p:cNvSpPr txBox="1"/>
+          <p:nvPr/>
+        </p:nvSpPr>
+        <p:spPr>
+          <a:xfrm>
+            <a:off x="1051560" y="2642616"/>
+            <a:ext cx="5029200" cy="246888"/>
+          </a:xfrm>
+          <a:prstGeom prst="rect">
+            <a:avLst/>
+          </a:prstGeom>
+          <a:noFill/>
+        </p:spPr>
+        <p:txBody>
+          <a:bodyPr wrap="square" anchor="t" lIns="0" rIns="0" tIns="0" bIns="0">
+            <a:spAutoFit/>
+          </a:bodyPr>
+          <a:lstStyle/>
+          <a:p>
+            <a:pPr algn="l"/>
+            <a:r>
+              <a:rPr sz="1300" b="0">
+                <a:solidFill>
+                  <a:srgbClr val="D8DAE2"/>
+                </a:solidFill>
+                <a:latin typeface="Consolas"/>
+              </a:rPr>
+              <a:t> </a:t>
+            </a:r>
+          </a:p>
+        </p:txBody>
+      </p:sp>
+      <p:sp>
+        <p:nvSpPr>
+          <p:cNvPr id="10" name="TextBox 9"/>
+          <p:cNvSpPr txBox="1"/>
+          <p:nvPr/>
+        </p:nvSpPr>
+        <p:spPr>
+          <a:xfrm>
+            <a:off x="1051560" y="2889504"/>
+            <a:ext cx="5029200" cy="246888"/>
+          </a:xfrm>
+          <a:prstGeom prst="rect">
+            <a:avLst/>
+          </a:prstGeom>
+          <a:noFill/>
+        </p:spPr>
+        <p:txBody>
+          <a:bodyPr wrap="square" anchor="t" lIns="0" rIns="0" tIns="0" bIns="0">
+            <a:spAutoFit/>
+          </a:bodyPr>
+          <a:lstStyle/>
+          <a:p>
+            <a:pPr algn="l"/>
+            <a:r>
+              <a:rPr sz="1300" b="0">
+                <a:solidFill>
+                  <a:srgbClr val="D8DAE2"/>
+                </a:solidFill>
+                <a:latin typeface="Consolas"/>
+              </a:rPr>
+              <a:t>model = models.Sequential()</a:t>
+            </a:r>
+          </a:p>
+        </p:txBody>
+      </p:sp>
+      <p:sp>
+        <p:nvSpPr>
+          <p:cNvPr id="11" name="TextBox 10"/>
+          <p:cNvSpPr txBox="1"/>
+          <p:nvPr/>
+        </p:nvSpPr>
+        <p:spPr>
+          <a:xfrm>
+            <a:off x="1051560" y="3136392"/>
+            <a:ext cx="5029200" cy="246888"/>
+          </a:xfrm>
+          <a:prstGeom prst="rect">
+            <a:avLst/>
+          </a:prstGeom>
+          <a:noFill/>
+        </p:spPr>
+        <p:txBody>
+          <a:bodyPr wrap="square" anchor="t" lIns="0" rIns="0" tIns="0" bIns="0">
+            <a:spAutoFit/>
+          </a:bodyPr>
+          <a:lstStyle/>
+          <a:p>
+            <a:pPr algn="l"/>
+            <a:r>
+              <a:rPr sz="1300" b="0">
+                <a:solidFill>
+                  <a:srgbClr val="FAD878"/>
+                </a:solidFill>
+                <a:latin typeface="Consolas"/>
+              </a:rPr>
+              <a:t>model.add(layers.Conv2D(3, (5, 5), activation='relu',</a:t>
+            </a:r>
+          </a:p>
+        </p:txBody>
+      </p:sp>
+      <p:sp>
+        <p:nvSpPr>
+          <p:cNvPr id="12" name="TextBox 11"/>
+          <p:cNvSpPr txBox="1"/>
+          <p:nvPr/>
+        </p:nvSpPr>
+        <p:spPr>
+          <a:xfrm>
+            <a:off x="1051560" y="3383280"/>
+            <a:ext cx="5029200" cy="246888"/>
+          </a:xfrm>
+          <a:prstGeom prst="rect">
+            <a:avLst/>
+          </a:prstGeom>
+          <a:noFill/>
+        </p:spPr>
+        <p:txBody>
+          <a:bodyPr wrap="square" anchor="t" lIns="0" rIns="0" tIns="0" bIns="0">
+            <a:spAutoFit/>
+          </a:bodyPr>
+          <a:lstStyle/>
+          <a:p>
+            <a:pPr algn="l"/>
+            <a:r>
+              <a:rPr sz="1300" b="0">
+                <a:solidFill>
+                  <a:srgbClr val="FAD878"/>
+                </a:solidFill>
+                <a:latin typeface="Consolas"/>
+              </a:rPr>
+              <a:t>                        input_shape=(28, 28, 1)))</a:t>
+            </a:r>
+          </a:p>
+        </p:txBody>
+      </p:sp>
+      <p:sp>
+        <p:nvSpPr>
+          <p:cNvPr id="13" name="TextBox 12"/>
+          <p:cNvSpPr txBox="1"/>
+          <p:nvPr/>
+        </p:nvSpPr>
+        <p:spPr>
+          <a:xfrm>
+            <a:off x="1051560" y="3630168"/>
+            <a:ext cx="5029200" cy="246888"/>
+          </a:xfrm>
+          <a:prstGeom prst="rect">
+            <a:avLst/>
+          </a:prstGeom>
+          <a:noFill/>
+        </p:spPr>
+        <p:txBody>
+          <a:bodyPr wrap="square" anchor="t" lIns="0" rIns="0" tIns="0" bIns="0">
+            <a:spAutoFit/>
+          </a:bodyPr>
+          <a:lstStyle/>
+          <a:p>
+            <a:pPr algn="l"/>
+            <a:r>
+              <a:rPr sz="1300" b="0">
+                <a:solidFill>
+                  <a:srgbClr val="D8DAE2"/>
+                </a:solidFill>
+                <a:latin typeface="Consolas"/>
+              </a:rPr>
+              <a:t>model.add(layers.MaxPooling2D((2, 2)))</a:t>
+            </a:r>
+          </a:p>
+        </p:txBody>
+      </p:sp>
+      <p:sp>
+        <p:nvSpPr>
+          <p:cNvPr id="14" name="TextBox 13"/>
+          <p:cNvSpPr txBox="1"/>
+          <p:nvPr/>
+        </p:nvSpPr>
+        <p:spPr>
+          <a:xfrm>
+            <a:off x="1051560" y="3877056"/>
+            <a:ext cx="5029200" cy="246888"/>
+          </a:xfrm>
+          <a:prstGeom prst="rect">
+            <a:avLst/>
+          </a:prstGeom>
+          <a:noFill/>
+        </p:spPr>
+        <p:txBody>
+          <a:bodyPr wrap="square" anchor="t" lIns="0" rIns="0" tIns="0" bIns="0">
+            <a:spAutoFit/>
+          </a:bodyPr>
+          <a:lstStyle/>
+          <a:p>
+            <a:pPr algn="l"/>
+            <a:r>
+              <a:rPr sz="1300" b="0">
+                <a:solidFill>
+                  <a:srgbClr val="FAD878"/>
+                </a:solidFill>
+                <a:latin typeface="Consolas"/>
+              </a:rPr>
+              <a:t>model.add(layers.Conv2D(5, (3, 3), activation='relu'))</a:t>
+            </a:r>
+          </a:p>
+        </p:txBody>
+      </p:sp>
+      <p:sp>
+        <p:nvSpPr>
+          <p:cNvPr id="15" name="TextBox 14"/>
+          <p:cNvSpPr txBox="1"/>
+          <p:nvPr/>
+        </p:nvSpPr>
+        <p:spPr>
+          <a:xfrm>
+            <a:off x="1051560" y="4123944"/>
+            <a:ext cx="5029200" cy="246888"/>
+          </a:xfrm>
+          <a:prstGeom prst="rect">
+            <a:avLst/>
+          </a:prstGeom>
+          <a:noFill/>
+        </p:spPr>
+        <p:txBody>
+          <a:bodyPr wrap="square" anchor="t" lIns="0" rIns="0" tIns="0" bIns="0">
+            <a:spAutoFit/>
+          </a:bodyPr>
+          <a:lstStyle/>
+          <a:p>
+            <a:pPr algn="l"/>
+            <a:r>
+              <a:rPr sz="1300" b="0">
+                <a:solidFill>
+                  <a:srgbClr val="D8DAE2"/>
+                </a:solidFill>
+                <a:latin typeface="Consolas"/>
+              </a:rPr>
+              <a:t>model.add(layers.MaxPooling2D((2, 2)))</a:t>
+            </a:r>
+          </a:p>
+        </p:txBody>
+      </p:sp>
+      <p:sp>
+        <p:nvSpPr>
+          <p:cNvPr id="16" name="TextBox 15"/>
+          <p:cNvSpPr txBox="1"/>
+          <p:nvPr/>
+        </p:nvSpPr>
+        <p:spPr>
+          <a:xfrm>
+            <a:off x="1051560" y="4370832"/>
+            <a:ext cx="5029200" cy="246888"/>
+          </a:xfrm>
+          <a:prstGeom prst="rect">
+            <a:avLst/>
+          </a:prstGeom>
+          <a:noFill/>
+        </p:spPr>
+        <p:txBody>
+          <a:bodyPr wrap="square" anchor="t" lIns="0" rIns="0" tIns="0" bIns="0">
+            <a:spAutoFit/>
+          </a:bodyPr>
+          <a:lstStyle/>
+          <a:p>
+            <a:pPr algn="l"/>
+            <a:r>
+              <a:rPr sz="1300" b="0">
+                <a:solidFill>
+                  <a:srgbClr val="D8DAE2"/>
+                </a:solidFill>
+                <a:latin typeface="Consolas"/>
+              </a:rPr>
+              <a:t>model.add(layers.Flatten())</a:t>
+            </a:r>
+          </a:p>
+        </p:txBody>
+      </p:sp>
+      <p:sp>
+        <p:nvSpPr>
+          <p:cNvPr id="17" name="TextBox 16"/>
+          <p:cNvSpPr txBox="1"/>
+          <p:nvPr/>
+        </p:nvSpPr>
+        <p:spPr>
+          <a:xfrm>
+            <a:off x="1051560" y="4617720"/>
+            <a:ext cx="5029200" cy="246888"/>
+          </a:xfrm>
+          <a:prstGeom prst="rect">
+            <a:avLst/>
+          </a:prstGeom>
+          <a:noFill/>
+        </p:spPr>
+        <p:txBody>
+          <a:bodyPr wrap="square" anchor="t" lIns="0" rIns="0" tIns="0" bIns="0">
+            <a:spAutoFit/>
+          </a:bodyPr>
+          <a:lstStyle/>
+          <a:p>
+            <a:pPr algn="l"/>
+            <a:r>
+              <a:rPr sz="1300" b="0">
+                <a:solidFill>
+                  <a:srgbClr val="FAD878"/>
+                </a:solidFill>
+                <a:latin typeface="Consolas"/>
+              </a:rPr>
+              <a:t>model.add(layers.Dense(256, activation='relu'))</a:t>
+            </a:r>
+          </a:p>
+        </p:txBody>
+      </p:sp>
+      <p:sp>
+        <p:nvSpPr>
+          <p:cNvPr id="18" name="TextBox 17"/>
+          <p:cNvSpPr txBox="1"/>
+          <p:nvPr/>
+        </p:nvSpPr>
+        <p:spPr>
+          <a:xfrm>
+            <a:off x="1051560" y="4864608"/>
+            <a:ext cx="5029200" cy="246888"/>
+          </a:xfrm>
+          <a:prstGeom prst="rect">
+            <a:avLst/>
+          </a:prstGeom>
+          <a:noFill/>
+        </p:spPr>
+        <p:txBody>
+          <a:bodyPr wrap="square" anchor="t" lIns="0" rIns="0" tIns="0" bIns="0">
+            <a:spAutoFit/>
+          </a:bodyPr>
+          <a:lstStyle/>
+          <a:p>
+            <a:pPr algn="l"/>
+            <a:r>
+              <a:rPr sz="1300" b="0">
+                <a:solidFill>
+                  <a:srgbClr val="FAD878"/>
+                </a:solidFill>
+                <a:latin typeface="Consolas"/>
+              </a:rPr>
+              <a:t>model.add(layers.Dense(2, activation='softmax'))</a:t>
+            </a:r>
+          </a:p>
+        </p:txBody>
+      </p:sp>
+      <p:sp>
+        <p:nvSpPr>
+          <p:cNvPr id="19" name="TextBox 18"/>
+          <p:cNvSpPr txBox="1"/>
+          <p:nvPr/>
+        </p:nvSpPr>
+        <p:spPr>
+          <a:xfrm>
+            <a:off x="1051560" y="5111496"/>
+            <a:ext cx="5029200" cy="246888"/>
+          </a:xfrm>
+          <a:prstGeom prst="rect">
+            <a:avLst/>
+          </a:prstGeom>
+          <a:noFill/>
+        </p:spPr>
+        <p:txBody>
+          <a:bodyPr wrap="square" anchor="t" lIns="0" rIns="0" tIns="0" bIns="0">
+            <a:spAutoFit/>
+          </a:bodyPr>
+          <a:lstStyle/>
+          <a:p>
+            <a:pPr algn="l"/>
+            <a:r>
+              <a:rPr sz="1300" b="0">
+                <a:solidFill>
+                  <a:srgbClr val="D8DAE2"/>
+                </a:solidFill>
+                <a:latin typeface="Consolas"/>
+              </a:rPr>
+              <a:t> </a:t>
+            </a:r>
+          </a:p>
+        </p:txBody>
+      </p:sp>
+      <p:sp>
+        <p:nvSpPr>
+          <p:cNvPr id="20" name="TextBox 19"/>
+          <p:cNvSpPr txBox="1"/>
+          <p:nvPr/>
+        </p:nvSpPr>
+        <p:spPr>
+          <a:xfrm>
+            <a:off x="1051560" y="5358384"/>
+            <a:ext cx="5029200" cy="246888"/>
+          </a:xfrm>
+          <a:prstGeom prst="rect">
+            <a:avLst/>
+          </a:prstGeom>
+          <a:noFill/>
+        </p:spPr>
+        <p:txBody>
+          <a:bodyPr wrap="square" anchor="t" lIns="0" rIns="0" tIns="0" bIns="0">
+            <a:spAutoFit/>
+          </a:bodyPr>
+          <a:lstStyle/>
+          <a:p>
+            <a:pPr algn="l"/>
+            <a:r>
+              <a:rPr sz="1300" b="0">
+                <a:solidFill>
+                  <a:srgbClr val="D8DAE2"/>
+                </a:solidFill>
+                <a:latin typeface="Consolas"/>
+              </a:rPr>
+              <a:t>model.summary()</a:t>
+            </a:r>
+          </a:p>
+        </p:txBody>
+      </p:sp>
+      <p:sp>
+        <p:nvSpPr>
+          <p:cNvPr id="21" name="Rounded Rectangle 20"/>
+          <p:cNvSpPr/>
+          <p:nvPr/>
+        </p:nvSpPr>
+        <p:spPr>
+          <a:xfrm>
+            <a:off x="6400800" y="1874519"/>
+            <a:ext cx="5029200" cy="3977639"/>
+          </a:xfrm>
+          <a:prstGeom prst="roundRect">
+            <a:avLst>
+              <a:gd name="adj" fmla="val 6000"/>
+            </a:avLst>
+          </a:prstGeom>
+          <a:solidFill>
+            <a:srgbClr val="FFFBEE"/>
+          </a:solidFill>
+          <a:ln w="27940">
+            <a:solidFill>
+              <a:srgbClr val="F2B705"/>
+            </a:solidFill>
+          </a:ln>
+          <a:effectLst/>
+        </p:spPr>
+        <p:style>
+          <a:lnRef idx="1">
+            <a:schemeClr val="accent1"/>
+          </a:lnRef>
+          <a:fillRef idx="3">
+            <a:schemeClr val="accent1"/>
+          </a:fillRef>
+          <a:effectRef idx="2">
+            <a:schemeClr val="accent1"/>
+          </a:effectRef>
+          <a:fontRef idx="minor">
+            <a:schemeClr val="lt1"/>
+          </a:fontRef>
+        </p:style>
+        <p:txBody>
+          <a:bodyPr rtlCol="0" anchor="ctr"/>
+          <a:lstStyle/>
+          <a:p>
+            <a:pPr algn="ctr"/>
+          </a:p>
+        </p:txBody>
+      </p:sp>
+      <p:sp>
+        <p:nvSpPr>
+          <p:cNvPr id="22" name="TextBox 21"/>
+          <p:cNvSpPr txBox="1"/>
+          <p:nvPr/>
+        </p:nvSpPr>
+        <p:spPr>
+          <a:xfrm>
+            <a:off x="6720840" y="2075688"/>
+            <a:ext cx="4389120" cy="365760"/>
+          </a:xfrm>
+          <a:prstGeom prst="rect">
+            <a:avLst/>
+          </a:prstGeom>
+          <a:noFill/>
+        </p:spPr>
+        <p:txBody>
+          <a:bodyPr wrap="square" anchor="t" lIns="0" rIns="0" tIns="0" bIns="0">
+            <a:spAutoFit/>
+          </a:bodyPr>
+          <a:lstStyle/>
+          <a:p>
+            <a:pPr algn="l"/>
+            <a:r>
+              <a:rPr sz="1600" b="1">
+                <a:solidFill>
+                  <a:srgbClr val="8C6908"/>
+                </a:solidFill>
+                <a:latin typeface="Arial"/>
+              </a:rPr>
+              <a:t>WHAT MODEL.SUMMARY() WILL PRINT</a:t>
+            </a:r>
+          </a:p>
+        </p:txBody>
+      </p:sp>
+      <p:sp>
+        <p:nvSpPr>
+          <p:cNvPr id="23" name="TextBox 22"/>
+          <p:cNvSpPr txBox="1"/>
+          <p:nvPr/>
+        </p:nvSpPr>
+        <p:spPr>
+          <a:xfrm>
+            <a:off x="6720840" y="2395728"/>
+            <a:ext cx="2103120" cy="320040"/>
+          </a:xfrm>
+          <a:prstGeom prst="rect">
+            <a:avLst/>
+          </a:prstGeom>
+          <a:noFill/>
+        </p:spPr>
+        <p:txBody>
+          <a:bodyPr wrap="square" anchor="t" lIns="0" rIns="0" tIns="0" bIns="0">
+            <a:spAutoFit/>
+          </a:bodyPr>
+          <a:lstStyle/>
+          <a:p>
+            <a:pPr algn="l"/>
+            <a:r>
+              <a:rPr sz="1300" b="0">
                 <a:solidFill>
                   <a:srgbClr val="1C1E24"/>
                 </a:solidFill>
-                <a:latin typeface="Arial"/>
-              </a:rPr>
-              <a:t>Given the code on the right, can you produce the summary on the left - every shape, every parameter count - BY HAND?</a:t>
-            </a:r>
-          </a:p>
-          <a:p>
-            <a:pPr algn="l">
-              <a:lnSpc>
-                <a:spcPct val="110000"/>
-              </a:lnSpc>
-            </a:pPr>
-            <a:r>
-              <a:rPr sz="1500" b="0">
+                <a:latin typeface="Consolas"/>
+              </a:rPr>
+              <a:t>conv2d (Conv2D)</a:t>
+            </a:r>
+          </a:p>
+        </p:txBody>
+      </p:sp>
+      <p:sp>
+        <p:nvSpPr>
+          <p:cNvPr id="24" name="TextBox 23"/>
+          <p:cNvSpPr txBox="1"/>
+          <p:nvPr/>
+        </p:nvSpPr>
+        <p:spPr>
+          <a:xfrm>
+            <a:off x="8732520" y="2395728"/>
+            <a:ext cx="1737360" cy="320040"/>
+          </a:xfrm>
+          <a:prstGeom prst="rect">
+            <a:avLst/>
+          </a:prstGeom>
+          <a:noFill/>
+        </p:spPr>
+        <p:txBody>
+          <a:bodyPr wrap="square" anchor="t" lIns="0" rIns="0" tIns="0" bIns="0">
+            <a:spAutoFit/>
+          </a:bodyPr>
+          <a:lstStyle/>
+          <a:p>
+            <a:pPr algn="l"/>
+            <a:r>
+              <a:rPr sz="1300" b="0">
+                <a:solidFill>
+                  <a:srgbClr val="787C86"/>
+                </a:solidFill>
+                <a:latin typeface="Consolas"/>
+              </a:rPr>
+              <a:t>(None, 24, 24, 3)</a:t>
+            </a:r>
+          </a:p>
+        </p:txBody>
+      </p:sp>
+      <p:sp>
+        <p:nvSpPr>
+          <p:cNvPr id="25" name="TextBox 24"/>
+          <p:cNvSpPr txBox="1"/>
+          <p:nvPr/>
+        </p:nvSpPr>
+        <p:spPr>
+          <a:xfrm>
+            <a:off x="10561320" y="2395728"/>
+            <a:ext cx="731520" cy="320040"/>
+          </a:xfrm>
+          <a:prstGeom prst="rect">
+            <a:avLst/>
+          </a:prstGeom>
+          <a:noFill/>
+        </p:spPr>
+        <p:txBody>
+          <a:bodyPr wrap="square" anchor="t" lIns="0" rIns="0" tIns="0" bIns="0">
+            <a:spAutoFit/>
+          </a:bodyPr>
+          <a:lstStyle/>
+          <a:p>
+            <a:pPr algn="r"/>
+            <a:r>
+              <a:rPr sz="1300" b="1">
+                <a:solidFill>
+                  <a:srgbClr val="8C6908"/>
+                </a:solidFill>
+                <a:latin typeface="Consolas"/>
+              </a:rPr>
+              <a:t>78</a:t>
+            </a:r>
+          </a:p>
+        </p:txBody>
+      </p:sp>
+      <p:sp>
+        <p:nvSpPr>
+          <p:cNvPr id="26" name="TextBox 25"/>
+          <p:cNvSpPr txBox="1"/>
+          <p:nvPr/>
+        </p:nvSpPr>
+        <p:spPr>
+          <a:xfrm>
+            <a:off x="6720840" y="2779776"/>
+            <a:ext cx="2103120" cy="320040"/>
+          </a:xfrm>
+          <a:prstGeom prst="rect">
+            <a:avLst/>
+          </a:prstGeom>
+          <a:noFill/>
+        </p:spPr>
+        <p:txBody>
+          <a:bodyPr wrap="square" anchor="t" lIns="0" rIns="0" tIns="0" bIns="0">
+            <a:spAutoFit/>
+          </a:bodyPr>
+          <a:lstStyle/>
+          <a:p>
+            <a:pPr algn="l"/>
+            <a:r>
+              <a:rPr sz="1300" b="0">
+                <a:solidFill>
+                  <a:srgbClr val="1C1E24"/>
+                </a:solidFill>
+                <a:latin typeface="Consolas"/>
+              </a:rPr>
+              <a:t>max_pooling2d</a:t>
+            </a:r>
+          </a:p>
+        </p:txBody>
+      </p:sp>
+      <p:sp>
+        <p:nvSpPr>
+          <p:cNvPr id="27" name="TextBox 26"/>
+          <p:cNvSpPr txBox="1"/>
+          <p:nvPr/>
+        </p:nvSpPr>
+        <p:spPr>
+          <a:xfrm>
+            <a:off x="8732520" y="2779776"/>
+            <a:ext cx="1737360" cy="320040"/>
+          </a:xfrm>
+          <a:prstGeom prst="rect">
+            <a:avLst/>
+          </a:prstGeom>
+          <a:noFill/>
+        </p:spPr>
+        <p:txBody>
+          <a:bodyPr wrap="square" anchor="t" lIns="0" rIns="0" tIns="0" bIns="0">
+            <a:spAutoFit/>
+          </a:bodyPr>
+          <a:lstStyle/>
+          <a:p>
+            <a:pPr algn="l"/>
+            <a:r>
+              <a:rPr sz="1300" b="0">
+                <a:solidFill>
+                  <a:srgbClr val="787C86"/>
+                </a:solidFill>
+                <a:latin typeface="Consolas"/>
+              </a:rPr>
+              <a:t>(None, 12, 12, 3)</a:t>
+            </a:r>
+          </a:p>
+        </p:txBody>
+      </p:sp>
+      <p:sp>
+        <p:nvSpPr>
+          <p:cNvPr id="28" name="TextBox 27"/>
+          <p:cNvSpPr txBox="1"/>
+          <p:nvPr/>
+        </p:nvSpPr>
+        <p:spPr>
+          <a:xfrm>
+            <a:off x="10561320" y="2779776"/>
+            <a:ext cx="731520" cy="320040"/>
+          </a:xfrm>
+          <a:prstGeom prst="rect">
+            <a:avLst/>
+          </a:prstGeom>
+          <a:noFill/>
+        </p:spPr>
+        <p:txBody>
+          <a:bodyPr wrap="square" anchor="t" lIns="0" rIns="0" tIns="0" bIns="0">
+            <a:spAutoFit/>
+          </a:bodyPr>
+          <a:lstStyle/>
+          <a:p>
+            <a:pPr algn="r"/>
+            <a:r>
+              <a:rPr sz="1300" b="0">
+                <a:solidFill>
+                  <a:srgbClr val="787C86"/>
+                </a:solidFill>
+                <a:latin typeface="Consolas"/>
+              </a:rPr>
+              <a:t>0</a:t>
+            </a:r>
+          </a:p>
+        </p:txBody>
+      </p:sp>
+      <p:sp>
+        <p:nvSpPr>
+          <p:cNvPr id="29" name="TextBox 28"/>
+          <p:cNvSpPr txBox="1"/>
+          <p:nvPr/>
+        </p:nvSpPr>
+        <p:spPr>
+          <a:xfrm>
+            <a:off x="6720840" y="3163824"/>
+            <a:ext cx="2103120" cy="320040"/>
+          </a:xfrm>
+          <a:prstGeom prst="rect">
+            <a:avLst/>
+          </a:prstGeom>
+          <a:noFill/>
+        </p:spPr>
+        <p:txBody>
+          <a:bodyPr wrap="square" anchor="t" lIns="0" rIns="0" tIns="0" bIns="0">
+            <a:spAutoFit/>
+          </a:bodyPr>
+          <a:lstStyle/>
+          <a:p>
+            <a:pPr algn="l"/>
+            <a:r>
+              <a:rPr sz="1300" b="0">
+                <a:solidFill>
+                  <a:srgbClr val="1C1E24"/>
+                </a:solidFill>
+                <a:latin typeface="Consolas"/>
+              </a:rPr>
+              <a:t>conv2d_1 (Conv2D)</a:t>
+            </a:r>
+          </a:p>
+        </p:txBody>
+      </p:sp>
+      <p:sp>
+        <p:nvSpPr>
+          <p:cNvPr id="30" name="TextBox 29"/>
+          <p:cNvSpPr txBox="1"/>
+          <p:nvPr/>
+        </p:nvSpPr>
+        <p:spPr>
+          <a:xfrm>
+            <a:off x="8732520" y="3163824"/>
+            <a:ext cx="1737360" cy="320040"/>
+          </a:xfrm>
+          <a:prstGeom prst="rect">
+            <a:avLst/>
+          </a:prstGeom>
+          <a:noFill/>
+        </p:spPr>
+        <p:txBody>
+          <a:bodyPr wrap="square" anchor="t" lIns="0" rIns="0" tIns="0" bIns="0">
+            <a:spAutoFit/>
+          </a:bodyPr>
+          <a:lstStyle/>
+          <a:p>
+            <a:pPr algn="l"/>
+            <a:r>
+              <a:rPr sz="1300" b="0">
+                <a:solidFill>
+                  <a:srgbClr val="787C86"/>
+                </a:solidFill>
+                <a:latin typeface="Consolas"/>
+              </a:rPr>
+              <a:t>(None, 10, 10, 5)</a:t>
+            </a:r>
+          </a:p>
+        </p:txBody>
+      </p:sp>
+      <p:sp>
+        <p:nvSpPr>
+          <p:cNvPr id="31" name="TextBox 30"/>
+          <p:cNvSpPr txBox="1"/>
+          <p:nvPr/>
+        </p:nvSpPr>
+        <p:spPr>
+          <a:xfrm>
+            <a:off x="10561320" y="3163824"/>
+            <a:ext cx="731520" cy="320040"/>
+          </a:xfrm>
+          <a:prstGeom prst="rect">
+            <a:avLst/>
+          </a:prstGeom>
+          <a:noFill/>
+        </p:spPr>
+        <p:txBody>
+          <a:bodyPr wrap="square" anchor="t" lIns="0" rIns="0" tIns="0" bIns="0">
+            <a:spAutoFit/>
+          </a:bodyPr>
+          <a:lstStyle/>
+          <a:p>
+            <a:pPr algn="r"/>
+            <a:r>
+              <a:rPr sz="1300" b="1">
+                <a:solidFill>
+                  <a:srgbClr val="8C6908"/>
+                </a:solidFill>
+                <a:latin typeface="Consolas"/>
+              </a:rPr>
+              <a:t>140</a:t>
+            </a:r>
+          </a:p>
+        </p:txBody>
+      </p:sp>
+      <p:sp>
+        <p:nvSpPr>
+          <p:cNvPr id="32" name="TextBox 31"/>
+          <p:cNvSpPr txBox="1"/>
+          <p:nvPr/>
+        </p:nvSpPr>
+        <p:spPr>
+          <a:xfrm>
+            <a:off x="6720840" y="3547872"/>
+            <a:ext cx="2103120" cy="320040"/>
+          </a:xfrm>
+          <a:prstGeom prst="rect">
+            <a:avLst/>
+          </a:prstGeom>
+          <a:noFill/>
+        </p:spPr>
+        <p:txBody>
+          <a:bodyPr wrap="square" anchor="t" lIns="0" rIns="0" tIns="0" bIns="0">
+            <a:spAutoFit/>
+          </a:bodyPr>
+          <a:lstStyle/>
+          <a:p>
+            <a:pPr algn="l"/>
+            <a:r>
+              <a:rPr sz="1300" b="0">
+                <a:solidFill>
+                  <a:srgbClr val="1C1E24"/>
+                </a:solidFill>
+                <a:latin typeface="Consolas"/>
+              </a:rPr>
+              <a:t>max_pooling2d_1</a:t>
+            </a:r>
+          </a:p>
+        </p:txBody>
+      </p:sp>
+      <p:sp>
+        <p:nvSpPr>
+          <p:cNvPr id="33" name="TextBox 32"/>
+          <p:cNvSpPr txBox="1"/>
+          <p:nvPr/>
+        </p:nvSpPr>
+        <p:spPr>
+          <a:xfrm>
+            <a:off x="8732520" y="3547872"/>
+            <a:ext cx="1737360" cy="320040"/>
+          </a:xfrm>
+          <a:prstGeom prst="rect">
+            <a:avLst/>
+          </a:prstGeom>
+          <a:noFill/>
+        </p:spPr>
+        <p:txBody>
+          <a:bodyPr wrap="square" anchor="t" lIns="0" rIns="0" tIns="0" bIns="0">
+            <a:spAutoFit/>
+          </a:bodyPr>
+          <a:lstStyle/>
+          <a:p>
+            <a:pPr algn="l"/>
+            <a:r>
+              <a:rPr sz="1300" b="0">
+                <a:solidFill>
+                  <a:srgbClr val="787C86"/>
+                </a:solidFill>
+                <a:latin typeface="Consolas"/>
+              </a:rPr>
+              <a:t>(None, 5, 5, 5)</a:t>
+            </a:r>
+          </a:p>
+        </p:txBody>
+      </p:sp>
+      <p:sp>
+        <p:nvSpPr>
+          <p:cNvPr id="34" name="TextBox 33"/>
+          <p:cNvSpPr txBox="1"/>
+          <p:nvPr/>
+        </p:nvSpPr>
+        <p:spPr>
+          <a:xfrm>
+            <a:off x="10561320" y="3547872"/>
+            <a:ext cx="731520" cy="320040"/>
+          </a:xfrm>
+          <a:prstGeom prst="rect">
+            <a:avLst/>
+          </a:prstGeom>
+          <a:noFill/>
+        </p:spPr>
+        <p:txBody>
+          <a:bodyPr wrap="square" anchor="t" lIns="0" rIns="0" tIns="0" bIns="0">
+            <a:spAutoFit/>
+          </a:bodyPr>
+          <a:lstStyle/>
+          <a:p>
+            <a:pPr algn="r"/>
+            <a:r>
+              <a:rPr sz="1300" b="0">
+                <a:solidFill>
+                  <a:srgbClr val="787C86"/>
+                </a:solidFill>
+                <a:latin typeface="Consolas"/>
+              </a:rPr>
+              <a:t>0</a:t>
+            </a:r>
+          </a:p>
+        </p:txBody>
+      </p:sp>
+      <p:sp>
+        <p:nvSpPr>
+          <p:cNvPr id="35" name="TextBox 34"/>
+          <p:cNvSpPr txBox="1"/>
+          <p:nvPr/>
+        </p:nvSpPr>
+        <p:spPr>
+          <a:xfrm>
+            <a:off x="6720840" y="3931920"/>
+            <a:ext cx="2103120" cy="320040"/>
+          </a:xfrm>
+          <a:prstGeom prst="rect">
+            <a:avLst/>
+          </a:prstGeom>
+          <a:noFill/>
+        </p:spPr>
+        <p:txBody>
+          <a:bodyPr wrap="square" anchor="t" lIns="0" rIns="0" tIns="0" bIns="0">
+            <a:spAutoFit/>
+          </a:bodyPr>
+          <a:lstStyle/>
+          <a:p>
+            <a:pPr algn="l"/>
+            <a:r>
+              <a:rPr sz="1300" b="0">
+                <a:solidFill>
+                  <a:srgbClr val="1C1E24"/>
+                </a:solidFill>
+                <a:latin typeface="Consolas"/>
+              </a:rPr>
+              <a:t>flatten (Flatten)</a:t>
+            </a:r>
+          </a:p>
+        </p:txBody>
+      </p:sp>
+      <p:sp>
+        <p:nvSpPr>
+          <p:cNvPr id="36" name="TextBox 35"/>
+          <p:cNvSpPr txBox="1"/>
+          <p:nvPr/>
+        </p:nvSpPr>
+        <p:spPr>
+          <a:xfrm>
+            <a:off x="8732520" y="3931920"/>
+            <a:ext cx="1737360" cy="320040"/>
+          </a:xfrm>
+          <a:prstGeom prst="rect">
+            <a:avLst/>
+          </a:prstGeom>
+          <a:noFill/>
+        </p:spPr>
+        <p:txBody>
+          <a:bodyPr wrap="square" anchor="t" lIns="0" rIns="0" tIns="0" bIns="0">
+            <a:spAutoFit/>
+          </a:bodyPr>
+          <a:lstStyle/>
+          <a:p>
+            <a:pPr algn="l"/>
+            <a:r>
+              <a:rPr sz="1300" b="0">
+                <a:solidFill>
+                  <a:srgbClr val="787C86"/>
+                </a:solidFill>
+                <a:latin typeface="Consolas"/>
+              </a:rPr>
+              <a:t>(None, 125)</a:t>
+            </a:r>
+          </a:p>
+        </p:txBody>
+      </p:sp>
+      <p:sp>
+        <p:nvSpPr>
+          <p:cNvPr id="37" name="TextBox 36"/>
+          <p:cNvSpPr txBox="1"/>
+          <p:nvPr/>
+        </p:nvSpPr>
+        <p:spPr>
+          <a:xfrm>
+            <a:off x="10561320" y="3931920"/>
+            <a:ext cx="731520" cy="320040"/>
+          </a:xfrm>
+          <a:prstGeom prst="rect">
+            <a:avLst/>
+          </a:prstGeom>
+          <a:noFill/>
+        </p:spPr>
+        <p:txBody>
+          <a:bodyPr wrap="square" anchor="t" lIns="0" rIns="0" tIns="0" bIns="0">
+            <a:spAutoFit/>
+          </a:bodyPr>
+          <a:lstStyle/>
+          <a:p>
+            <a:pPr algn="r"/>
+            <a:r>
+              <a:rPr sz="1300" b="0">
+                <a:solidFill>
+                  <a:srgbClr val="787C86"/>
+                </a:solidFill>
+                <a:latin typeface="Consolas"/>
+              </a:rPr>
+              <a:t>0</a:t>
+            </a:r>
+          </a:p>
+        </p:txBody>
+      </p:sp>
+      <p:sp>
+        <p:nvSpPr>
+          <p:cNvPr id="38" name="TextBox 37"/>
+          <p:cNvSpPr txBox="1"/>
+          <p:nvPr/>
+        </p:nvSpPr>
+        <p:spPr>
+          <a:xfrm>
+            <a:off x="6720840" y="4315968"/>
+            <a:ext cx="2103120" cy="320040"/>
+          </a:xfrm>
+          <a:prstGeom prst="rect">
+            <a:avLst/>
+          </a:prstGeom>
+          <a:noFill/>
+        </p:spPr>
+        <p:txBody>
+          <a:bodyPr wrap="square" anchor="t" lIns="0" rIns="0" tIns="0" bIns="0">
+            <a:spAutoFit/>
+          </a:bodyPr>
+          <a:lstStyle/>
+          <a:p>
+            <a:pPr algn="l"/>
+            <a:r>
+              <a:rPr sz="1300" b="0">
+                <a:solidFill>
+                  <a:srgbClr val="1C1E24"/>
+                </a:solidFill>
+                <a:latin typeface="Consolas"/>
+              </a:rPr>
+              <a:t>dense (Dense)</a:t>
+            </a:r>
+          </a:p>
+        </p:txBody>
+      </p:sp>
+      <p:sp>
+        <p:nvSpPr>
+          <p:cNvPr id="39" name="TextBox 38"/>
+          <p:cNvSpPr txBox="1"/>
+          <p:nvPr/>
+        </p:nvSpPr>
+        <p:spPr>
+          <a:xfrm>
+            <a:off x="8732520" y="4315968"/>
+            <a:ext cx="1737360" cy="320040"/>
+          </a:xfrm>
+          <a:prstGeom prst="rect">
+            <a:avLst/>
+          </a:prstGeom>
+          <a:noFill/>
+        </p:spPr>
+        <p:txBody>
+          <a:bodyPr wrap="square" anchor="t" lIns="0" rIns="0" tIns="0" bIns="0">
+            <a:spAutoFit/>
+          </a:bodyPr>
+          <a:lstStyle/>
+          <a:p>
+            <a:pPr algn="l"/>
+            <a:r>
+              <a:rPr sz="1300" b="0">
+                <a:solidFill>
+                  <a:srgbClr val="787C86"/>
+                </a:solidFill>
+                <a:latin typeface="Consolas"/>
+              </a:rPr>
+              <a:t>(None, 256)</a:t>
+            </a:r>
+          </a:p>
+        </p:txBody>
+      </p:sp>
+      <p:sp>
+        <p:nvSpPr>
+          <p:cNvPr id="40" name="TextBox 39"/>
+          <p:cNvSpPr txBox="1"/>
+          <p:nvPr/>
+        </p:nvSpPr>
+        <p:spPr>
+          <a:xfrm>
+            <a:off x="10561320" y="4315968"/>
+            <a:ext cx="731520" cy="320040"/>
+          </a:xfrm>
+          <a:prstGeom prst="rect">
+            <a:avLst/>
+          </a:prstGeom>
+          <a:noFill/>
+        </p:spPr>
+        <p:txBody>
+          <a:bodyPr wrap="square" anchor="t" lIns="0" rIns="0" tIns="0" bIns="0">
+            <a:spAutoFit/>
+          </a:bodyPr>
+          <a:lstStyle/>
+          <a:p>
+            <a:pPr algn="r"/>
+            <a:r>
+              <a:rPr sz="1300" b="1">
+                <a:solidFill>
+                  <a:srgbClr val="8C6908"/>
+                </a:solidFill>
+                <a:latin typeface="Consolas"/>
+              </a:rPr>
+              <a:t>32,256</a:t>
+            </a:r>
+          </a:p>
+        </p:txBody>
+      </p:sp>
+      <p:sp>
+        <p:nvSpPr>
+          <p:cNvPr id="41" name="TextBox 40"/>
+          <p:cNvSpPr txBox="1"/>
+          <p:nvPr/>
+        </p:nvSpPr>
+        <p:spPr>
+          <a:xfrm>
+            <a:off x="6720840" y="4700016"/>
+            <a:ext cx="2103120" cy="320040"/>
+          </a:xfrm>
+          <a:prstGeom prst="rect">
+            <a:avLst/>
+          </a:prstGeom>
+          <a:noFill/>
+        </p:spPr>
+        <p:txBody>
+          <a:bodyPr wrap="square" anchor="t" lIns="0" rIns="0" tIns="0" bIns="0">
+            <a:spAutoFit/>
+          </a:bodyPr>
+          <a:lstStyle/>
+          <a:p>
+            <a:pPr algn="l"/>
+            <a:r>
+              <a:rPr sz="1300" b="0">
+                <a:solidFill>
+                  <a:srgbClr val="1C1E24"/>
+                </a:solidFill>
+                <a:latin typeface="Consolas"/>
+              </a:rPr>
+              <a:t>dense_1 (Dense)</a:t>
+            </a:r>
+          </a:p>
+        </p:txBody>
+      </p:sp>
+      <p:sp>
+        <p:nvSpPr>
+          <p:cNvPr id="42" name="TextBox 41"/>
+          <p:cNvSpPr txBox="1"/>
+          <p:nvPr/>
+        </p:nvSpPr>
+        <p:spPr>
+          <a:xfrm>
+            <a:off x="8732520" y="4700016"/>
+            <a:ext cx="1737360" cy="320040"/>
+          </a:xfrm>
+          <a:prstGeom prst="rect">
+            <a:avLst/>
+          </a:prstGeom>
+          <a:noFill/>
+        </p:spPr>
+        <p:txBody>
+          <a:bodyPr wrap="square" anchor="t" lIns="0" rIns="0" tIns="0" bIns="0">
+            <a:spAutoFit/>
+          </a:bodyPr>
+          <a:lstStyle/>
+          <a:p>
+            <a:pPr algn="l"/>
+            <a:r>
+              <a:rPr sz="1300" b="0">
+                <a:solidFill>
+                  <a:srgbClr val="787C86"/>
+                </a:solidFill>
+                <a:latin typeface="Consolas"/>
+              </a:rPr>
+              <a:t>(None, 2)</a:t>
+            </a:r>
+          </a:p>
+        </p:txBody>
+      </p:sp>
+      <p:sp>
+        <p:nvSpPr>
+          <p:cNvPr id="43" name="TextBox 42"/>
+          <p:cNvSpPr txBox="1"/>
+          <p:nvPr/>
+        </p:nvSpPr>
+        <p:spPr>
+          <a:xfrm>
+            <a:off x="10561320" y="4700016"/>
+            <a:ext cx="731520" cy="320040"/>
+          </a:xfrm>
+          <a:prstGeom prst="rect">
+            <a:avLst/>
+          </a:prstGeom>
+          <a:noFill/>
+        </p:spPr>
+        <p:txBody>
+          <a:bodyPr wrap="square" anchor="t" lIns="0" rIns="0" tIns="0" bIns="0">
+            <a:spAutoFit/>
+          </a:bodyPr>
+          <a:lstStyle/>
+          <a:p>
+            <a:pPr algn="r"/>
+            <a:r>
+              <a:rPr sz="1300" b="1">
+                <a:solidFill>
+                  <a:srgbClr val="8C6908"/>
+                </a:solidFill>
+                <a:latin typeface="Consolas"/>
+              </a:rPr>
+              <a:t>514</a:t>
+            </a:r>
+          </a:p>
+        </p:txBody>
+      </p:sp>
+      <p:cxnSp>
+        <p:nvCxnSpPr>
+          <p:cNvPr id="44" name="Connector 43"/>
+          <p:cNvCxnSpPr/>
+          <p:nvPr/>
+        </p:nvCxnSpPr>
+        <p:spPr>
+          <a:xfrm>
+            <a:off x="6720840" y="5138928"/>
+            <a:ext cx="4572000" cy="0"/>
+          </a:xfrm>
+          <a:prstGeom prst="line">
+            <a:avLst/>
+          </a:prstGeom>
+          <a:ln w="19050">
+            <a:solidFill>
+              <a:srgbClr val="8C6908"/>
+            </a:solidFill>
+          </a:ln>
+          <a:effectLst/>
+        </p:spPr>
+        <p:style>
+          <a:lnRef idx="2">
+            <a:schemeClr val="accent1"/>
+          </a:lnRef>
+          <a:fillRef idx="0">
+            <a:schemeClr val="accent1"/>
+          </a:fillRef>
+          <a:effectRef idx="1">
+            <a:schemeClr val="accent1"/>
+          </a:effectRef>
+          <a:fontRef idx="minor">
+            <a:schemeClr val="tx1"/>
+          </a:fontRef>
+        </p:style>
+      </p:cxnSp>
+      <p:sp>
+        <p:nvSpPr>
+          <p:cNvPr id="45" name="TextBox 44"/>
+          <p:cNvSpPr txBox="1"/>
+          <p:nvPr/>
+        </p:nvSpPr>
+        <p:spPr>
+          <a:xfrm>
+            <a:off x="6720840" y="5248656"/>
+            <a:ext cx="3108960" cy="365760"/>
+          </a:xfrm>
+          <a:prstGeom prst="rect">
+            <a:avLst/>
+          </a:prstGeom>
+          <a:noFill/>
+        </p:spPr>
+        <p:txBody>
+          <a:bodyPr wrap="square" anchor="t" lIns="0" rIns="0" tIns="0" bIns="0">
+            <a:spAutoFit/>
+          </a:bodyPr>
+          <a:lstStyle/>
+          <a:p>
+            <a:pPr algn="l"/>
+            <a:r>
+              <a:rPr sz="1500" b="1">
+                <a:solidFill>
+                  <a:srgbClr val="1C1E24"/>
+                </a:solidFill>
+                <a:latin typeface="Consolas"/>
+              </a:rPr>
+              <a:t>Total params:</a:t>
+            </a:r>
+          </a:p>
+        </p:txBody>
+      </p:sp>
+      <p:sp>
+        <p:nvSpPr>
+          <p:cNvPr id="46" name="TextBox 45"/>
+          <p:cNvSpPr txBox="1"/>
+          <p:nvPr/>
+        </p:nvSpPr>
+        <p:spPr>
+          <a:xfrm>
+            <a:off x="9875520" y="5230368"/>
+            <a:ext cx="1417320" cy="384048"/>
+          </a:xfrm>
+          <a:prstGeom prst="rect">
+            <a:avLst/>
+          </a:prstGeom>
+          <a:noFill/>
+        </p:spPr>
+        <p:txBody>
+          <a:bodyPr wrap="square" anchor="t" lIns="0" rIns="0" tIns="0" bIns="0">
+            <a:spAutoFit/>
+          </a:bodyPr>
+          <a:lstStyle/>
+          <a:p>
+            <a:pPr algn="r"/>
+            <a:r>
+              <a:rPr sz="1800" b="1">
+                <a:solidFill>
+                  <a:srgbClr val="1C1E24"/>
+                </a:solidFill>
+                <a:latin typeface="Consolas"/>
+              </a:rPr>
+              <a:t>32,988</a:t>
+            </a:r>
+          </a:p>
+        </p:txBody>
+      </p:sp>
+      <p:sp>
+        <p:nvSpPr>
+          <p:cNvPr id="47" name="TextBox 46"/>
+          <p:cNvSpPr txBox="1"/>
+          <p:nvPr/>
+        </p:nvSpPr>
+        <p:spPr>
+          <a:xfrm>
+            <a:off x="777240" y="6053328"/>
+            <a:ext cx="10652760" cy="365760"/>
+          </a:xfrm>
+          <a:prstGeom prst="rect">
+            <a:avLst/>
+          </a:prstGeom>
+          <a:noFill/>
+        </p:spPr>
+        <p:txBody>
+          <a:bodyPr wrap="square" anchor="t" lIns="0" rIns="0" tIns="0" bIns="0">
+            <a:spAutoFit/>
+          </a:bodyPr>
+          <a:lstStyle/>
+          <a:p>
+            <a:pPr algn="l"/>
+            <a:r>
+              <a:rPr sz="1500" b="1">
+                <a:solidFill>
+                  <a:srgbClr val="1C1E24"/>
+                </a:solidFill>
+                <a:latin typeface="Arial"/>
+              </a:rPr>
+              <a:t>Given the code, produce the summary by hand - every shape, every count. </a:t>
+            </a:r>
+            <a:r>
+              <a:rPr sz="1500" b="1">
                 <a:solidFill>
                   <a:srgbClr val="9A780A"/>
                 </a:solidFill>
@@ -24577,7 +25978,7 @@
       </p:sp>
       <p:sp>
         <p:nvSpPr>
-          <p:cNvPr id="9" name="Rectangle 8"/>
+          <p:cNvPr id="48" name="Rectangle 47"/>
           <p:cNvSpPr/>
           <p:nvPr/>
         </p:nvSpPr>
@@ -24621,7 +26022,7 @@
       </p:sp>
       <p:sp>
         <p:nvSpPr>
-          <p:cNvPr id="10" name="Rectangle 9"/>
+          <p:cNvPr id="49" name="Rectangle 48"/>
           <p:cNvSpPr/>
           <p:nvPr/>
         </p:nvSpPr>
@@ -24665,7 +26066,7 @@
       </p:sp>
       <p:sp>
         <p:nvSpPr>
-          <p:cNvPr id="11" name="TextBox 10"/>
+          <p:cNvPr id="50" name="TextBox 49"/>
           <p:cNvSpPr txBox="1"/>
           <p:nvPr/>
         </p:nvSpPr>
@@ -24700,7 +26101,7 @@
       </p:sp>
       <p:sp>
         <p:nvSpPr>
-          <p:cNvPr id="12" name="TextBox 11"/>
+          <p:cNvPr id="51" name="TextBox 50"/>
           <p:cNvSpPr txBox="1"/>
           <p:nvPr/>
         </p:nvSpPr>
@@ -28275,7 +29676,7 @@
                 </a:solidFill>
                 <a:latin typeface="Arial"/>
               </a:rPr>
-              <a:t>20,132</a:t>
+              <a:t>32,988</a:t>
             </a:r>
           </a:p>
         </p:txBody>
@@ -28310,7 +29711,7 @@
                 </a:solidFill>
                 <a:latin typeface="Arial"/>
               </a:rPr>
-              <a:t>parameters - 20x fewer, and it handles shifted/rotated images</a:t>
+              <a:t>parameters - 12x fewer, and it handles shifted/rotated images</a:t>
             </a:r>
           </a:p>
         </p:txBody>
@@ -28345,7 +29746,7 @@
                 </a:solidFill>
                 <a:latin typeface="Arial"/>
               </a:rPr>
-              <a:t>Fewer parameters, better behavior. The rest of this deck shows exactly where 20,132 comes from.</a:t>
+              <a:t>Fewer parameters, better behavior. The rest of this deck shows exactly where 32,988 comes from.</a:t>
             </a:r>
           </a:p>
         </p:txBody>
@@ -29957,7 +31358,132 @@
       </p:sp>
       <p:sp>
         <p:nvSpPr>
-          <p:cNvPr id="12" name="Rectangle 11"/>
+          <p:cNvPr id="12" name="Rounded Rectangle 11"/>
+          <p:cNvSpPr/>
+          <p:nvPr/>
+        </p:nvSpPr>
+        <p:spPr>
+          <a:xfrm>
+            <a:off x="777240" y="5532120"/>
+            <a:ext cx="10652760" cy="658368"/>
+          </a:xfrm>
+          <a:prstGeom prst="roundRect">
+            <a:avLst>
+              <a:gd name="adj" fmla="val 30000"/>
+            </a:avLst>
+          </a:prstGeom>
+          <a:solidFill>
+            <a:srgbClr val="181A20"/>
+          </a:solidFill>
+          <a:ln>
+            <a:noFill/>
+          </a:ln>
+          <a:effectLst/>
+        </p:spPr>
+        <p:style>
+          <a:lnRef idx="1">
+            <a:schemeClr val="accent1"/>
+          </a:lnRef>
+          <a:fillRef idx="3">
+            <a:schemeClr val="accent1"/>
+          </a:fillRef>
+          <a:effectRef idx="2">
+            <a:schemeClr val="accent1"/>
+          </a:effectRef>
+          <a:fontRef idx="minor">
+            <a:schemeClr val="lt1"/>
+          </a:fontRef>
+        </p:style>
+        <p:txBody>
+          <a:bodyPr rtlCol="0" anchor="ctr"/>
+          <a:lstStyle/>
+          <a:p>
+            <a:pPr algn="ctr"/>
+          </a:p>
+        </p:txBody>
+      </p:sp>
+      <p:sp>
+        <p:nvSpPr>
+          <p:cNvPr id="13" name="TextBox 12"/>
+          <p:cNvSpPr txBox="1"/>
+          <p:nvPr/>
+        </p:nvSpPr>
+        <p:spPr>
+          <a:xfrm>
+            <a:off x="1097280" y="5614416"/>
+            <a:ext cx="10058400" cy="274320"/>
+          </a:xfrm>
+          <a:prstGeom prst="rect">
+            <a:avLst/>
+          </a:prstGeom>
+          <a:noFill/>
+        </p:spPr>
+        <p:txBody>
+          <a:bodyPr wrap="square" anchor="t" lIns="0" rIns="0" tIns="0" bIns="0">
+            <a:spAutoFit/>
+          </a:bodyPr>
+          <a:lstStyle/>
+          <a:p>
+            <a:pPr algn="l"/>
+            <a:r>
+              <a:rPr sz="1500" b="1">
+                <a:solidFill>
+                  <a:srgbClr val="FAD878"/>
+                </a:solidFill>
+                <a:latin typeface="Arial"/>
+              </a:rPr>
+              <a:t>WORKED:  </a:t>
+            </a:r>
+            <a:r>
+              <a:rPr sz="1500" b="0">
+                <a:solidFill>
+                  <a:srgbClr val="D2D4DC"/>
+                </a:solidFill>
+                <a:latin typeface="Arial"/>
+              </a:rPr>
+              <a:t>28x28 image, 5x5 kernel, F=3  -&gt;  size: 28 - (5-1) = 24, so (None,28,28,1) becomes (None,24,24,3)  ·  parms: ((5x5x1)+1)x3 = 78</a:t>
+            </a:r>
+          </a:p>
+        </p:txBody>
+      </p:sp>
+      <p:sp>
+        <p:nvSpPr>
+          <p:cNvPr id="14" name="TextBox 13"/>
+          <p:cNvSpPr txBox="1"/>
+          <p:nvPr/>
+        </p:nvSpPr>
+        <p:spPr>
+          <a:xfrm>
+            <a:off x="1097280" y="5897880"/>
+            <a:ext cx="10058400" cy="274320"/>
+          </a:xfrm>
+          <a:prstGeom prst="rect">
+            <a:avLst/>
+          </a:prstGeom>
+          <a:noFill/>
+        </p:spPr>
+        <p:txBody>
+          <a:bodyPr wrap="square" anchor="t" lIns="0" rIns="0" tIns="0" bIns="0">
+            <a:spAutoFit/>
+          </a:bodyPr>
+          <a:lstStyle/>
+          <a:p>
+            <a:pPr algn="l"/>
+            <a:r>
+              <a:rPr sz="1400" b="1">
+                <a:solidFill>
+                  <a:srgbClr val="FAD878"/>
+                </a:solidFill>
+                <a:latin typeface="Arial"/>
+              </a:rPr>
+              <a:t>"Size" = the rows/cols of the map. That little shrink IS the light downsampling. (Pooling does the aggressive kind: 24 / 2 = 12.)</a:t>
+            </a:r>
+          </a:p>
+        </p:txBody>
+      </p:sp>
+      <p:sp>
+        <p:nvSpPr>
+          <p:cNvPr id="15" name="Rectangle 14"/>
           <p:cNvSpPr/>
           <p:nvPr/>
         </p:nvSpPr>
@@ -30001,7 +31527,7 @@
       </p:sp>
       <p:sp>
         <p:nvSpPr>
-          <p:cNvPr id="13" name="Rectangle 12"/>
+          <p:cNvPr id="16" name="Rectangle 15"/>
           <p:cNvSpPr/>
           <p:nvPr/>
         </p:nvSpPr>
@@ -30045,7 +31571,7 @@
       </p:sp>
       <p:sp>
         <p:nvSpPr>
-          <p:cNvPr id="14" name="TextBox 13"/>
+          <p:cNvPr id="17" name="TextBox 16"/>
           <p:cNvSpPr txBox="1"/>
           <p:nvPr/>
         </p:nvSpPr>
@@ -30080,7 +31606,7 @@
       </p:sp>
       <p:sp>
         <p:nvSpPr>
-          <p:cNvPr id="15" name="TextBox 14"/>
+          <p:cNvPr id="18" name="TextBox 17"/>
           <p:cNvSpPr txBox="1"/>
           <p:nvPr/>
         </p:nvSpPr>
@@ -31222,7 +32748,7 @@
                 </a:solidFill>
                 <a:latin typeface="Arial"/>
               </a:rPr>
-              <a:t>Conv2D 3 @ 3x3</a:t>
+              <a:t>Conv2D 5 @ 3x3</a:t>
             </a:r>
           </a:p>
         </p:txBody>
@@ -31257,7 +32783,7 @@
                 </a:solidFill>
                 <a:latin typeface="Arial"/>
               </a:rPr>
-              <a:t>(None, 10, 10, 3)</a:t>
+              <a:t>(None, 10, 10, 5)</a:t>
             </a:r>
           </a:p>
         </p:txBody>
@@ -31411,7 +32937,7 @@
                 </a:solidFill>
                 <a:latin typeface="Arial"/>
               </a:rPr>
-              <a:t>(None, 5, 5, 3)</a:t>
+              <a:t>(None, 5, 5, 5)</a:t>
             </a:r>
           </a:p>
         </p:txBody>
@@ -31565,7 +33091,7 @@
                 </a:solidFill>
                 <a:latin typeface="Arial"/>
               </a:rPr>
-              <a:t>(None, 75)</a:t>
+              <a:t>(None, 125)</a:t>
             </a:r>
           </a:p>
         </p:txBody>
@@ -33231,7 +34757,7 @@
                 </a:solidFill>
                 <a:latin typeface="Arial"/>
               </a:rPr>
-              <a:t>Conv2D 3 @ 3x3</a:t>
+              <a:t>Conv2D 5 @ 3x3</a:t>
             </a:r>
           </a:p>
         </p:txBody>
@@ -33266,7 +34792,7 @@
                 </a:solidFill>
                 <a:latin typeface="Arial"/>
               </a:rPr>
-              <a:t>(None, 10, 10, 3)</a:t>
+              <a:t>(None, 10, 10, 5)</a:t>
             </a:r>
           </a:p>
         </p:txBody>
@@ -33420,7 +34946,7 @@
                 </a:solidFill>
                 <a:latin typeface="Arial"/>
               </a:rPr>
-              <a:t>(None, 5, 5, 3)</a:t>
+              <a:t>(None, 5, 5, 5)</a:t>
             </a:r>
           </a:p>
         </p:txBody>
@@ -33574,7 +35100,7 @@
                 </a:solidFill>
                 <a:latin typeface="Arial"/>
               </a:rPr>
-              <a:t>(None, 75)</a:t>
+              <a:t>(None, 125)</a:t>
             </a:r>
           </a:p>
         </p:txBody>
@@ -35321,7 +36847,7 @@
                 </a:solidFill>
                 <a:latin typeface="Arial"/>
               </a:rPr>
-              <a:t>Conv2D 3 @ 3x3</a:t>
+              <a:t>Conv2D 5 @ 3x3</a:t>
             </a:r>
           </a:p>
         </p:txBody>
@@ -35356,7 +36882,7 @@
                 </a:solidFill>
                 <a:latin typeface="Arial"/>
               </a:rPr>
-              <a:t>(None, 10, 10, 3)</a:t>
+              <a:t>(None, 10, 10, 5)</a:t>
             </a:r>
           </a:p>
         </p:txBody>
@@ -35510,7 +37036,7 @@
                 </a:solidFill>
                 <a:latin typeface="Arial"/>
               </a:rPr>
-              <a:t>(None, 5, 5, 3)</a:t>
+              <a:t>(None, 5, 5, 5)</a:t>
             </a:r>
           </a:p>
         </p:txBody>
@@ -35664,7 +37190,7 @@
                 </a:solidFill>
                 <a:latin typeface="Arial"/>
               </a:rPr>
-              <a:t>(None, 75)</a:t>
+              <a:t>(None, 125)</a:t>
             </a:r>
           </a:p>
         </p:txBody>

</xml_diff>

<commit_message>
Fix slide 5 worked-strip overflow in math deck
Co-Authored-By: Claude Fable 5 <noreply@anthropic.com>
</commit_message>
<xml_diff>
--- a/OPIM5509_Module3_Files/slides/Math for a Simple ConvNet.pptx
+++ b/OPIM5509_Module3_Files/slides/Math for a Simple ConvNet.pptx
@@ -31411,7 +31411,7 @@
         <p:spPr>
           <a:xfrm>
             <a:off x="1097280" y="5614416"/>
-            <a:ext cx="10058400" cy="274320"/>
+            <a:ext cx="10149840" cy="274320"/>
           </a:xfrm>
           <a:prstGeom prst="rect">
             <a:avLst/>
@@ -31426,7 +31426,7 @@
           <a:p>
             <a:pPr algn="l"/>
             <a:r>
-              <a:rPr sz="1500" b="1">
+              <a:rPr sz="1300" b="1">
                 <a:solidFill>
                   <a:srgbClr val="FAD878"/>
                 </a:solidFill>
@@ -31435,13 +31435,13 @@
               <a:t>WORKED:  </a:t>
             </a:r>
             <a:r>
-              <a:rPr sz="1500" b="0">
+              <a:rPr sz="1300" b="0">
                 <a:solidFill>
                   <a:srgbClr val="D2D4DC"/>
                 </a:solidFill>
                 <a:latin typeface="Arial"/>
               </a:rPr>
-              <a:t>28x28 image, 5x5 kernel, F=3  -&gt;  size: 28 - (5-1) = 24, so (None,28,28,1) becomes (None,24,24,3)  ·  parms: ((5x5x1)+1)x3 = 78</a:t>
+              <a:t>28x28 image, 5x5 kernel, F=3  -&gt;  size: 28-(5-1)=24 -&gt; (None,24,24,3)  ·  parms: ((5x5x1)+1)x3 = 78</a:t>
             </a:r>
           </a:p>
         </p:txBody>
@@ -31454,8 +31454,8 @@
         </p:nvSpPr>
         <p:spPr>
           <a:xfrm>
-            <a:off x="1097280" y="5897880"/>
-            <a:ext cx="10058400" cy="274320"/>
+            <a:off x="1097280" y="5888736"/>
+            <a:ext cx="10149840" cy="274320"/>
           </a:xfrm>
           <a:prstGeom prst="rect">
             <a:avLst/>
@@ -31470,13 +31470,13 @@
           <a:p>
             <a:pPr algn="l"/>
             <a:r>
-              <a:rPr sz="1400" b="1">
+              <a:rPr sz="1300" b="1">
                 <a:solidFill>
                   <a:srgbClr val="FAD878"/>
                 </a:solidFill>
                 <a:latin typeface="Arial"/>
               </a:rPr>
-              <a:t>"Size" = the rows/cols of the map. That little shrink IS the light downsampling. (Pooling does the aggressive kind: 24 / 2 = 12.)</a:t>
+              <a:t>"Size" = the rows/cols of the map. That little shrink IS the light downsampling. (Pooling is the aggressive kind: 24/2 = 12.)</a:t>
             </a:r>
           </a:p>
         </p:txBody>

</xml_diff>